<commit_message>
patch for minor bugs
</commit_message>
<xml_diff>
--- a/group_project.pptx
+++ b/group_project.pptx
@@ -146,6 +146,9 @@
           </p14:sldIdLst>
         </p14:section>
       </p14:sectionLst>
+    </p:ext>
+    <p:ext uri="{EFAFB233-063F-42B5-8137-9DF3F51BA10A}">
+      <p15:sldGuideLst xmlns:p15="http://schemas.microsoft.com/office/powerpoint/2012/main"/>
     </p:ext>
   </p:extLst>
 </p:presentation>
@@ -2941,7 +2944,7 @@
           </a:lstStyle>
           <a:p>
             <a:fld id="{19B8080D-2B2C-4C48-AB13-97E85EBAF0A4}" type="datetimeFigureOut">
-              <a:t>3/31/2026</a:t>
+              <a:t>4/1/2026</a:t>
             </a:fld>
             <a:endParaRPr lang="en-US"/>
           </a:p>
@@ -5582,7 +5585,7 @@
           <a:p>
             <a:fld id="{846CE7D5-CF57-46EF-B807-FDD0502418D4}" type="datetimeFigureOut">
               <a:rPr lang="en-US" smtClean="0"/>
-              <a:t>3/31/2026</a:t>
+              <a:t>4/1/2026</a:t>
             </a:fld>
             <a:endParaRPr lang="en-US"/>
           </a:p>
@@ -5750,7 +5753,7 @@
           <a:p>
             <a:fld id="{846CE7D5-CF57-46EF-B807-FDD0502418D4}" type="datetimeFigureOut">
               <a:rPr lang="en-US" smtClean="0"/>
-              <a:t>3/31/2026</a:t>
+              <a:t>4/1/2026</a:t>
             </a:fld>
             <a:endParaRPr lang="en-US"/>
           </a:p>
@@ -5928,7 +5931,7 @@
           <a:p>
             <a:fld id="{846CE7D5-CF57-46EF-B807-FDD0502418D4}" type="datetimeFigureOut">
               <a:rPr lang="en-US" smtClean="0"/>
-              <a:t>3/31/2026</a:t>
+              <a:t>4/1/2026</a:t>
             </a:fld>
             <a:endParaRPr lang="en-US"/>
           </a:p>
@@ -6126,7 +6129,7 @@
           <a:p>
             <a:fld id="{846CE7D5-CF57-46EF-B807-FDD0502418D4}" type="datetimeFigureOut">
               <a:rPr lang="en-US" smtClean="0"/>
-              <a:t>3/31/2026</a:t>
+              <a:t>4/1/2026</a:t>
             </a:fld>
             <a:endParaRPr lang="en-US"/>
           </a:p>
@@ -6371,7 +6374,7 @@
           <a:p>
             <a:fld id="{846CE7D5-CF57-46EF-B807-FDD0502418D4}" type="datetimeFigureOut">
               <a:rPr lang="en-US" smtClean="0"/>
-              <a:t>3/31/2026</a:t>
+              <a:t>4/1/2026</a:t>
             </a:fld>
             <a:endParaRPr lang="en-US"/>
           </a:p>
@@ -6600,7 +6603,7 @@
           <a:p>
             <a:fld id="{846CE7D5-CF57-46EF-B807-FDD0502418D4}" type="datetimeFigureOut">
               <a:rPr lang="en-US" smtClean="0"/>
-              <a:t>3/31/2026</a:t>
+              <a:t>4/1/2026</a:t>
             </a:fld>
             <a:endParaRPr lang="en-US"/>
           </a:p>
@@ -6964,7 +6967,7 @@
           <a:p>
             <a:fld id="{846CE7D5-CF57-46EF-B807-FDD0502418D4}" type="datetimeFigureOut">
               <a:rPr lang="en-US" smtClean="0"/>
-              <a:t>3/31/2026</a:t>
+              <a:t>4/1/2026</a:t>
             </a:fld>
             <a:endParaRPr lang="en-US"/>
           </a:p>
@@ -7081,7 +7084,7 @@
           <a:p>
             <a:fld id="{846CE7D5-CF57-46EF-B807-FDD0502418D4}" type="datetimeFigureOut">
               <a:rPr lang="en-US" smtClean="0"/>
-              <a:t>3/31/2026</a:t>
+              <a:t>4/1/2026</a:t>
             </a:fld>
             <a:endParaRPr lang="en-US"/>
           </a:p>
@@ -7176,7 +7179,7 @@
           <a:p>
             <a:fld id="{846CE7D5-CF57-46EF-B807-FDD0502418D4}" type="datetimeFigureOut">
               <a:rPr lang="en-US" smtClean="0"/>
-              <a:t>3/31/2026</a:t>
+              <a:t>4/1/2026</a:t>
             </a:fld>
             <a:endParaRPr lang="en-US"/>
           </a:p>
@@ -7451,7 +7454,7 @@
           <a:p>
             <a:fld id="{846CE7D5-CF57-46EF-B807-FDD0502418D4}" type="datetimeFigureOut">
               <a:rPr lang="en-US" smtClean="0"/>
-              <a:t>3/31/2026</a:t>
+              <a:t>4/1/2026</a:t>
             </a:fld>
             <a:endParaRPr lang="en-US"/>
           </a:p>
@@ -7706,7 +7709,7 @@
           <a:p>
             <a:fld id="{846CE7D5-CF57-46EF-B807-FDD0502418D4}" type="datetimeFigureOut">
               <a:rPr lang="en-US" smtClean="0"/>
-              <a:t>3/31/2026</a:t>
+              <a:t>4/1/2026</a:t>
             </a:fld>
             <a:endParaRPr lang="en-US"/>
           </a:p>
@@ -7920,7 +7923,7 @@
           <a:p>
             <a:fld id="{846CE7D5-CF57-46EF-B807-FDD0502418D4}" type="datetimeFigureOut">
               <a:rPr lang="en-US" smtClean="0"/>
-              <a:t>3/31/2026</a:t>
+              <a:t>4/1/2026</a:t>
             </a:fld>
             <a:endParaRPr lang="en-US"/>
           </a:p>
@@ -9072,9 +9075,11 @@
               <a:buNone/>
             </a:pPr>
             <a:r>
-              <a:rPr lang="en-US" sz="5867" b="1">
-                <a:solidFill>
-                  <a:srgbClr val="FFFFFF"/>
+              <a:rPr lang="en-US" sz="5867" b="1" dirty="0">
+                <a:solidFill>
+                  <a:schemeClr val="accent1">
+                    <a:lumMod val="50000"/>
+                  </a:schemeClr>
                 </a:solidFill>
                 <a:latin typeface="Calibri" pitchFamily="34" charset="0"/>
                 <a:ea typeface="Calibri" pitchFamily="34" charset="-122"/>
@@ -9082,7 +9087,13 @@
               </a:rPr>
               <a:t>Telco Customer Churn</a:t>
             </a:r>
-            <a:endParaRPr lang="en-US" sz="5867"/>
+            <a:endParaRPr lang="en-US" sz="5867" dirty="0">
+              <a:solidFill>
+                <a:schemeClr val="accent1">
+                  <a:lumMod val="50000"/>
+                </a:schemeClr>
+              </a:solidFill>
+            </a:endParaRPr>
           </a:p>
         </p:txBody>
       </p:sp>
@@ -9455,9 +9466,11 @@
               <a:buNone/>
             </a:pPr>
             <a:r>
-              <a:rPr lang="en-US" sz="1600">
-                <a:solidFill>
-                  <a:srgbClr val="CBD5E1"/>
+              <a:rPr lang="en-US" sz="1600" dirty="0">
+                <a:solidFill>
+                  <a:schemeClr val="accent1">
+                    <a:lumMod val="50000"/>
+                  </a:schemeClr>
                 </a:solidFill>
                 <a:latin typeface="Calibri" pitchFamily="34" charset="0"/>
                 <a:ea typeface="Calibri" pitchFamily="34" charset="-122"/>
@@ -9465,7 +9478,13 @@
               </a:rPr>
               <a:t>Using IBM Telco Dataset  •  Machine Learning Pipeline  •  SHAP Explainability</a:t>
             </a:r>
-            <a:endParaRPr lang="en-US" sz="1600"/>
+            <a:endParaRPr lang="en-US" sz="1600" dirty="0">
+              <a:solidFill>
+                <a:schemeClr val="accent1">
+                  <a:lumMod val="50000"/>
+                </a:schemeClr>
+              </a:solidFill>
+            </a:endParaRPr>
           </a:p>
         </p:txBody>
       </p:sp>
@@ -33040,9 +33059,11 @@
               <a:buNone/>
             </a:pPr>
             <a:r>
-              <a:rPr lang="en-US" sz="4000" b="1">
-                <a:solidFill>
-                  <a:srgbClr val="FFFFFF"/>
+              <a:rPr lang="en-US" sz="4000" b="1" dirty="0">
+                <a:solidFill>
+                  <a:schemeClr val="accent1">
+                    <a:lumMod val="50000"/>
+                  </a:schemeClr>
                 </a:solidFill>
                 <a:latin typeface="Calibri" pitchFamily="34" charset="0"/>
                 <a:ea typeface="Calibri" pitchFamily="34" charset="-122"/>
@@ -33050,7 +33071,6 @@
               </a:rPr>
               <a:t>EDA Summary &amp; What's Next</a:t>
             </a:r>
-            <a:endParaRPr lang="en-US" sz="4000"/>
           </a:p>
         </p:txBody>
       </p:sp>
@@ -33420,14 +33440,13 @@
               <a:buNone/>
             </a:pPr>
             <a:r>
-              <a:rPr lang="en-US" sz="1533">
-                <a:solidFill>
-                  <a:srgbClr val="FFFFFF"/>
+              <a:rPr lang="en-US" sz="1533" dirty="0">
+                <a:solidFill>
+                  <a:srgbClr val="FF0000"/>
                 </a:solidFill>
               </a:rPr>
               <a:t>Overall churn rate: 26.5% (~1 in 4 customers leave)</a:t>
             </a:r>
-            <a:endParaRPr lang="en-US" sz="1533"/>
           </a:p>
         </p:txBody>
       </p:sp>
@@ -33797,14 +33816,13 @@
               <a:buNone/>
             </a:pPr>
             <a:r>
-              <a:rPr lang="en-US" sz="1533">
-                <a:solidFill>
-                  <a:srgbClr val="FFFFFF"/>
+              <a:rPr lang="en-US" sz="1533" dirty="0">
+                <a:solidFill>
+                  <a:schemeClr val="accent2"/>
                 </a:solidFill>
               </a:rPr>
               <a:t>Month-to-month contracts: 42.7% churn vs 2.8% for 2-year</a:t>
             </a:r>
-            <a:endParaRPr lang="en-US" sz="1533"/>
           </a:p>
         </p:txBody>
       </p:sp>
@@ -34174,14 +34192,13 @@
               <a:buNone/>
             </a:pPr>
             <a:r>
-              <a:rPr lang="en-US" sz="1533">
-                <a:solidFill>
-                  <a:srgbClr val="FFFFFF"/>
+              <a:rPr lang="en-US" sz="1533" dirty="0">
+                <a:solidFill>
+                  <a:schemeClr val="accent2"/>
                 </a:solidFill>
               </a:rPr>
               <a:t>New customers (0-12 months) are at highest risk: ~48% churn</a:t>
             </a:r>
-            <a:endParaRPr lang="en-US" sz="1533"/>
           </a:p>
         </p:txBody>
       </p:sp>
@@ -34551,14 +34568,16 @@
               <a:buNone/>
             </a:pPr>
             <a:r>
-              <a:rPr lang="en-US" sz="1533">
-                <a:solidFill>
-                  <a:srgbClr val="FFFFFF"/>
+              <a:rPr lang="en-US" sz="1533" dirty="0">
+                <a:solidFill>
+                  <a:schemeClr val="tx2">
+                    <a:lumMod val="60000"/>
+                    <a:lumOff val="40000"/>
+                  </a:schemeClr>
                 </a:solidFill>
               </a:rPr>
               <a:t>Fiber optic users churn most despite being premium service</a:t>
             </a:r>
-            <a:endParaRPr lang="en-US" sz="1533"/>
           </a:p>
         </p:txBody>
       </p:sp>
@@ -34928,14 +34947,15 @@
               <a:buNone/>
             </a:pPr>
             <a:r>
-              <a:rPr lang="en-US" sz="1533">
-                <a:solidFill>
-                  <a:srgbClr val="FFFFFF"/>
+              <a:rPr lang="en-US" sz="1533" dirty="0">
+                <a:solidFill>
+                  <a:schemeClr val="accent1">
+                    <a:lumMod val="50000"/>
+                  </a:schemeClr>
                 </a:solidFill>
               </a:rPr>
               <a:t>Electronic check → highest churn; auto-pay methods → lowest</a:t>
             </a:r>
-            <a:endParaRPr lang="en-US" sz="1533"/>
           </a:p>
         </p:txBody>
       </p:sp>
@@ -41630,6 +41650,23 @@
 </file>
 
 <file path=customXml/item1.xml><?xml version="1.0" encoding="utf-8"?>
+<p:properties xmlns:p="http://schemas.microsoft.com/office/2006/metadata/properties" xmlns:xsi="http://www.w3.org/2001/XMLSchema-instance" xmlns:pc="http://schemas.microsoft.com/office/infopath/2007/PartnerControls">
+  <documentManagement>
+    <_activity xmlns="fe8e2d30-2088-4d97-aa7e-f53a4c1394b4" xsi:nil="true"/>
+  </documentManagement>
+</p:properties>
+</file>
+
+<file path=customXml/item2.xml><?xml version="1.0" encoding="utf-8"?>
+<?mso-contentType ?>
+<FormTemplates xmlns="http://schemas.microsoft.com/sharepoint/v3/contenttype/forms">
+  <Display>DocumentLibraryForm</Display>
+  <Edit>DocumentLibraryForm</Edit>
+  <New>DocumentLibraryForm</New>
+</FormTemplates>
+</file>
+
+<file path=customXml/item3.xml><?xml version="1.0" encoding="utf-8"?>
 <ct:contentTypeSchema xmlns:ct="http://schemas.microsoft.com/office/2006/metadata/contentType" xmlns:ma="http://schemas.microsoft.com/office/2006/metadata/properties/metaAttributes" ct:_="" ma:_="" ma:contentTypeName="Document" ma:contentTypeID="0x01010004FED5D5EACBD74D84B1BF5B4A8084F5" ma:contentTypeVersion="5" ma:contentTypeDescription="Create a new document." ma:contentTypeScope="" ma:versionID="d89d40ba71339f9646bedc7f3aa3f7db">
   <xsd:schema xmlns:xsd="http://www.w3.org/2001/XMLSchema" xmlns:xs="http://www.w3.org/2001/XMLSchema" xmlns:p="http://schemas.microsoft.com/office/2006/metadata/properties" xmlns:ns3="fe8e2d30-2088-4d97-aa7e-f53a4c1394b4" targetNamespace="http://schemas.microsoft.com/office/2006/metadata/properties" ma:root="true" ma:fieldsID="227b794506d0985b41e8e7115f607b5d" ns3:_="">
     <xsd:import namespace="fe8e2d30-2088-4d97-aa7e-f53a4c1394b4"/>
@@ -41779,24 +41816,31 @@
 </ct:contentTypeSchema>
 </file>
 
-<file path=customXml/item2.xml><?xml version="1.0" encoding="utf-8"?>
-<?mso-contentType ?>
-<FormTemplates xmlns="http://schemas.microsoft.com/sharepoint/v3/contenttype/forms">
-  <Display>DocumentLibraryForm</Display>
-  <Edit>DocumentLibraryForm</Edit>
-  <New>DocumentLibraryForm</New>
-</FormTemplates>
+<file path=customXml/itemProps1.xml><?xml version="1.0" encoding="utf-8"?>
+<ds:datastoreItem xmlns:ds="http://schemas.openxmlformats.org/officeDocument/2006/customXml" ds:itemID="{5AC4EBE8-82A4-46B6-8584-753405986C67}">
+  <ds:schemaRefs>
+    <ds:schemaRef ds:uri="fe8e2d30-2088-4d97-aa7e-f53a4c1394b4"/>
+    <ds:schemaRef ds:uri="http://purl.org/dc/dcmitype/"/>
+    <ds:schemaRef ds:uri="http://purl.org/dc/elements/1.1/"/>
+    <ds:schemaRef ds:uri="http://purl.org/dc/terms/"/>
+    <ds:schemaRef ds:uri="http://schemas.microsoft.com/office/2006/documentManagement/types"/>
+    <ds:schemaRef ds:uri="http://schemas.microsoft.com/office/2006/metadata/properties"/>
+    <ds:schemaRef ds:uri="http://schemas.microsoft.com/office/infopath/2007/PartnerControls"/>
+    <ds:schemaRef ds:uri="http://schemas.openxmlformats.org/package/2006/metadata/core-properties"/>
+    <ds:schemaRef ds:uri="http://www.w3.org/XML/1998/namespace"/>
+  </ds:schemaRefs>
+</ds:datastoreItem>
 </file>
 
-<file path=customXml/item3.xml><?xml version="1.0" encoding="utf-8"?>
-<p:properties xmlns:p="http://schemas.microsoft.com/office/2006/metadata/properties" xmlns:xsi="http://www.w3.org/2001/XMLSchema-instance" xmlns:pc="http://schemas.microsoft.com/office/infopath/2007/PartnerControls">
-  <documentManagement>
-    <_activity xmlns="fe8e2d30-2088-4d97-aa7e-f53a4c1394b4" xsi:nil="true"/>
-  </documentManagement>
-</p:properties>
+<file path=customXml/itemProps2.xml><?xml version="1.0" encoding="utf-8"?>
+<ds:datastoreItem xmlns:ds="http://schemas.openxmlformats.org/officeDocument/2006/customXml" ds:itemID="{057AAC0D-719D-4CDD-AA7C-1A388FEAD0D7}">
+  <ds:schemaRefs>
+    <ds:schemaRef ds:uri="http://schemas.microsoft.com/sharepoint/v3/contenttype/forms"/>
+  </ds:schemaRefs>
+</ds:datastoreItem>
 </file>
 
-<file path=customXml/itemProps1.xml><?xml version="1.0" encoding="utf-8"?>
+<file path=customXml/itemProps3.xml><?xml version="1.0" encoding="utf-8"?>
 <ds:datastoreItem xmlns:ds="http://schemas.openxmlformats.org/officeDocument/2006/customXml" ds:itemID="{155B37AA-B63B-4B03-B9CE-39387575488A}">
   <ds:schemaRefs>
     <ds:schemaRef ds:uri="fe8e2d30-2088-4d97-aa7e-f53a4c1394b4"/>
@@ -41812,28 +41856,4 @@
     <ds:schemaRef ds:uri="http://www.w3.org/2001/XMLSchema"/>
   </ds:schemaRefs>
 </ds:datastoreItem>
-</file>
-
-<file path=customXml/itemProps2.xml><?xml version="1.0" encoding="utf-8"?>
-<ds:datastoreItem xmlns:ds="http://schemas.openxmlformats.org/officeDocument/2006/customXml" ds:itemID="{057AAC0D-719D-4CDD-AA7C-1A388FEAD0D7}">
-  <ds:schemaRefs>
-    <ds:schemaRef ds:uri="http://schemas.microsoft.com/sharepoint/v3/contenttype/forms"/>
-  </ds:schemaRefs>
-</ds:datastoreItem>
-</file>
-
-<file path=customXml/itemProps3.xml><?xml version="1.0" encoding="utf-8"?>
-<ds:datastoreItem xmlns:ds="http://schemas.openxmlformats.org/officeDocument/2006/customXml" ds:itemID="{5AC4EBE8-82A4-46B6-8584-753405986C67}">
-  <ds:schemaRefs>
-    <ds:schemaRef ds:uri="fe8e2d30-2088-4d97-aa7e-f53a4c1394b4"/>
-    <ds:schemaRef ds:uri="http://purl.org/dc/dcmitype/"/>
-    <ds:schemaRef ds:uri="http://purl.org/dc/elements/1.1/"/>
-    <ds:schemaRef ds:uri="http://purl.org/dc/terms/"/>
-    <ds:schemaRef ds:uri="http://schemas.microsoft.com/office/2006/documentManagement/types"/>
-    <ds:schemaRef ds:uri="http://schemas.microsoft.com/office/2006/metadata/properties"/>
-    <ds:schemaRef ds:uri="http://schemas.microsoft.com/office/infopath/2007/PartnerControls"/>
-    <ds:schemaRef ds:uri="http://schemas.openxmlformats.org/package/2006/metadata/core-properties"/>
-    <ds:schemaRef ds:uri="http://www.w3.org/XML/1998/namespace"/>
-  </ds:schemaRefs>
-</ds:datastoreItem>
 </file>
</xml_diff>